<commit_message>
Fix backend connection leak, IoT memory leak, frontend debug logs and missing UI integrations
</commit_message>
<xml_diff>
--- a/SmartWaste360_Review1_Presentation.pptx
+++ b/SmartWaste360_Review1_Presentation.pptx
@@ -313,7 +313,7 @@
           <a:p>
             <a:fld id="{5BCAD085-E8A6-8845-BD4E-CB4CCA059FC4}" type="datetimeFigureOut">
               <a:rPr lang="en-US" smtClean="0"/>
-              <a:t>02-Mar-26</a:t>
+              <a:t>15-May-26</a:t>
             </a:fld>
             <a:endParaRPr lang="en-US"/>
           </a:p>
@@ -481,7 +481,7 @@
           <a:p>
             <a:fld id="{5BCAD085-E8A6-8845-BD4E-CB4CCA059FC4}" type="datetimeFigureOut">
               <a:rPr lang="en-US" smtClean="0"/>
-              <a:t>02-Mar-26</a:t>
+              <a:t>15-May-26</a:t>
             </a:fld>
             <a:endParaRPr lang="en-US"/>
           </a:p>
@@ -659,7 +659,7 @@
           <a:p>
             <a:fld id="{5BCAD085-E8A6-8845-BD4E-CB4CCA059FC4}" type="datetimeFigureOut">
               <a:rPr lang="en-US" smtClean="0"/>
-              <a:t>02-Mar-26</a:t>
+              <a:t>15-May-26</a:t>
             </a:fld>
             <a:endParaRPr lang="en-US"/>
           </a:p>
@@ -827,7 +827,7 @@
           <a:p>
             <a:fld id="{5BCAD085-E8A6-8845-BD4E-CB4CCA059FC4}" type="datetimeFigureOut">
               <a:rPr lang="en-US" smtClean="0"/>
-              <a:t>02-Mar-26</a:t>
+              <a:t>15-May-26</a:t>
             </a:fld>
             <a:endParaRPr lang="en-US"/>
           </a:p>
@@ -1072,7 +1072,7 @@
           <a:p>
             <a:fld id="{5BCAD085-E8A6-8845-BD4E-CB4CCA059FC4}" type="datetimeFigureOut">
               <a:rPr lang="en-US" smtClean="0"/>
-              <a:t>02-Mar-26</a:t>
+              <a:t>15-May-26</a:t>
             </a:fld>
             <a:endParaRPr lang="en-US"/>
           </a:p>
@@ -1357,7 +1357,7 @@
           <a:p>
             <a:fld id="{5BCAD085-E8A6-8845-BD4E-CB4CCA059FC4}" type="datetimeFigureOut">
               <a:rPr lang="en-US" smtClean="0"/>
-              <a:t>02-Mar-26</a:t>
+              <a:t>15-May-26</a:t>
             </a:fld>
             <a:endParaRPr lang="en-US"/>
           </a:p>
@@ -1776,7 +1776,7 @@
           <a:p>
             <a:fld id="{5BCAD085-E8A6-8845-BD4E-CB4CCA059FC4}" type="datetimeFigureOut">
               <a:rPr lang="en-US" smtClean="0"/>
-              <a:t>02-Mar-26</a:t>
+              <a:t>15-May-26</a:t>
             </a:fld>
             <a:endParaRPr lang="en-US"/>
           </a:p>
@@ -1893,7 +1893,7 @@
           <a:p>
             <a:fld id="{5BCAD085-E8A6-8845-BD4E-CB4CCA059FC4}" type="datetimeFigureOut">
               <a:rPr lang="en-US" smtClean="0"/>
-              <a:t>02-Mar-26</a:t>
+              <a:t>15-May-26</a:t>
             </a:fld>
             <a:endParaRPr lang="en-US"/>
           </a:p>
@@ -1988,7 +1988,7 @@
           <a:p>
             <a:fld id="{5BCAD085-E8A6-8845-BD4E-CB4CCA059FC4}" type="datetimeFigureOut">
               <a:rPr lang="en-US" smtClean="0"/>
-              <a:t>02-Mar-26</a:t>
+              <a:t>15-May-26</a:t>
             </a:fld>
             <a:endParaRPr lang="en-US"/>
           </a:p>
@@ -2263,7 +2263,7 @@
           <a:p>
             <a:fld id="{5BCAD085-E8A6-8845-BD4E-CB4CCA059FC4}" type="datetimeFigureOut">
               <a:rPr lang="en-US" smtClean="0"/>
-              <a:t>02-Mar-26</a:t>
+              <a:t>15-May-26</a:t>
             </a:fld>
             <a:endParaRPr lang="en-US"/>
           </a:p>
@@ -2515,7 +2515,7 @@
           <a:p>
             <a:fld id="{5BCAD085-E8A6-8845-BD4E-CB4CCA059FC4}" type="datetimeFigureOut">
               <a:rPr lang="en-US" smtClean="0"/>
-              <a:t>02-Mar-26</a:t>
+              <a:t>15-May-26</a:t>
             </a:fld>
             <a:endParaRPr lang="en-US"/>
           </a:p>
@@ -2726,7 +2726,7 @@
           <a:p>
             <a:fld id="{5BCAD085-E8A6-8845-BD4E-CB4CCA059FC4}" type="datetimeFigureOut">
               <a:rPr lang="en-US" smtClean="0"/>
-              <a:t>02-Mar-26</a:t>
+              <a:t>15-May-26</a:t>
             </a:fld>
             <a:endParaRPr lang="en-US"/>
           </a:p>
@@ -3424,8 +3424,7 @@
               </a:defRPr>
             </a:pPr>
             <a:r>
-              <a:rPr dirty="0"/>
-              <a:t>Theme-Based Project  |  Review-1</a:t>
+              <a:t>Theme-Based Project</a:t>
             </a:r>
             <a:br>
               <a:rPr dirty="0"/>

</xml_diff>